<commit_message>
add guided prompts and contact info to thank you slide
- add 01-setup/guided-prompts.md with 10 progressive workshop prompts
- add LinkedIn, Substack, GitHub links to slide 20 (thank you slide)

Co-Authored-By: Claude Opus 4.6 (1M context) <noreply@anthropic.com>
</commit_message>
<xml_diff>
--- a/02-presentation/Session-1-Claude-Code-NextLeap.pptx
+++ b/02-presentation/Session-1-Claude-Code-NextLeap.pptx
@@ -23,8 +23,7 @@
     <p:sldId id="272" r:id="rId17"/>
     <p:sldId id="278" r:id="rId18"/>
     <p:sldId id="277" r:id="rId19"/>
-    <p:sldId id="273" r:id="rId20"/>
-    <p:sldId id="274" r:id="rId21"/>
+    <p:sldId id="274" r:id="rId20"/>
   </p:sldIdLst>
   <p:sldSz cx="12188825" cy="6858000"/>
   <p:notesSz cx="6858000" cy="9144000"/>
@@ -4403,7 +4402,7 @@
           <a:lstStyle/>
           <a:p>
             <a:pPr algn="ctr"/>
-            <a:endParaRPr/>
+            <a:endParaRPr dirty="0"/>
           </a:p>
         </p:txBody>
       </p:sp>
@@ -4416,27 +4415,26 @@
         <p:spPr>
           <a:xfrm>
             <a:off x="502920" y="1783080"/>
-            <a:ext cx="3383280" cy="457200"/>
-          </a:xfrm>
-          <a:prstGeom prst="rect">
-            <a:avLst/>
-          </a:prstGeom>
-          <a:noFill/>
-        </p:spPr>
-        <p:txBody>
-          <a:bodyPr wrap="square">
-            <a:spAutoFit/>
-          </a:bodyPr>
-          <a:lstStyle/>
-          <a:p>
-            <a:pPr algn="l"/>
-            <a:r>
-              <a:rPr sz="1300" b="1">
+            <a:ext cx="3383280" cy="292388"/>
+          </a:xfrm>
+          <a:prstGeom prst="rect">
+            <a:avLst/>
+          </a:prstGeom>
+          <a:noFill/>
+        </p:spPr>
+        <p:txBody>
+          <a:bodyPr wrap="square">
+            <a:spAutoFit/>
+          </a:bodyPr>
+          <a:lstStyle/>
+          <a:p>
+            <a:r>
+              <a:rPr lang="en-IN" sz="1300" b="1" dirty="0">
                 <a:solidFill>
                   <a:srgbClr val="D47A21"/>
                 </a:solidFill>
               </a:rPr>
-              <a:t>GLOBAL</a:t>
+              <a:t>GLOBAL (Your Brain)</a:t>
             </a:r>
           </a:p>
         </p:txBody>
@@ -4533,7 +4531,7 @@
           <a:p>
             <a:pPr algn="l"/>
             <a:r>
-              <a:rPr sz="1400" b="0">
+              <a:rPr sz="1400" b="0" dirty="0">
                 <a:solidFill>
                   <a:srgbClr val="CCCCCC"/>
                 </a:solidFill>
@@ -4598,7 +4596,7 @@
         <p:spPr>
           <a:xfrm>
             <a:off x="4306824" y="1783080"/>
-            <a:ext cx="3383280" cy="457200"/>
+            <a:ext cx="3383280" cy="292388"/>
           </a:xfrm>
           <a:prstGeom prst="rect">
             <a:avLst/>
@@ -4613,13 +4611,26 @@
           <a:p>
             <a:pPr algn="l"/>
             <a:r>
-              <a:rPr sz="1300" b="1">
+              <a:rPr sz="1300" b="1" dirty="0">
                 <a:solidFill>
                   <a:srgbClr val="D47A21"/>
                 </a:solidFill>
               </a:rPr>
               <a:t>PROJECT</a:t>
             </a:r>
+            <a:r>
+              <a:rPr lang="en-US" sz="1300" b="1" dirty="0">
+                <a:solidFill>
+                  <a:srgbClr val="D47A21"/>
+                </a:solidFill>
+              </a:rPr>
+              <a:t> (Project Brain)</a:t>
+            </a:r>
+            <a:endParaRPr sz="1300" b="1" dirty="0">
+              <a:solidFill>
+                <a:srgbClr val="D47A21"/>
+              </a:solidFill>
+            </a:endParaRPr>
           </a:p>
         </p:txBody>
       </p:sp>
@@ -4780,7 +4791,7 @@
         <p:spPr>
           <a:xfrm>
             <a:off x="8110728" y="1783080"/>
-            <a:ext cx="3383280" cy="457200"/>
+            <a:ext cx="3383280" cy="292388"/>
           </a:xfrm>
           <a:prstGeom prst="rect">
             <a:avLst/>
@@ -4795,13 +4806,26 @@
           <a:p>
             <a:pPr algn="l"/>
             <a:r>
-              <a:rPr sz="1300" b="1">
+              <a:rPr sz="1300" b="1" dirty="0">
                 <a:solidFill>
                   <a:srgbClr val="D47A21"/>
                 </a:solidFill>
               </a:rPr>
               <a:t>SUBFOLDER</a:t>
             </a:r>
+            <a:r>
+              <a:rPr lang="en-US" sz="1300" b="1" dirty="0">
+                <a:solidFill>
+                  <a:srgbClr val="D47A21"/>
+                </a:solidFill>
+              </a:rPr>
+              <a:t> (Feature Brain)</a:t>
+            </a:r>
+            <a:endParaRPr sz="1300" b="1" dirty="0">
+              <a:solidFill>
+                <a:srgbClr val="D47A21"/>
+              </a:solidFill>
+            </a:endParaRPr>
           </a:p>
         </p:txBody>
       </p:sp>
@@ -7193,7 +7217,7 @@
         <p:spPr>
           <a:xfrm>
             <a:off x="548640" y="502920"/>
-            <a:ext cx="10058400" cy="822960"/>
+            <a:ext cx="10058400" cy="615553"/>
           </a:xfrm>
           <a:prstGeom prst="rect">
             <a:avLst/>
@@ -7208,13 +7232,26 @@
           <a:p>
             <a:pPr algn="l"/>
             <a:r>
+              <a:rPr sz="3400" b="1" dirty="0">
+                <a:solidFill>
+                  <a:srgbClr val="FFFFFF"/>
+                </a:solidFill>
+              </a:rPr>
+              <a:t>Three </a:t>
+            </a:r>
+            <a:r>
               <a:rPr sz="3400" b="1">
                 <a:solidFill>
                   <a:srgbClr val="FFFFFF"/>
                 </a:solidFill>
               </a:rPr>
-              <a:t>Three Starter Tasks for Sunday's Build Day</a:t>
-            </a:r>
+              <a:t>Starter Tasks</a:t>
+            </a:r>
+            <a:endParaRPr sz="3400" b="1" dirty="0">
+              <a:solidFill>
+                <a:srgbClr val="FFFFFF"/>
+              </a:solidFill>
+            </a:endParaRPr>
           </a:p>
         </p:txBody>
       </p:sp>
@@ -8791,7 +8828,7 @@
           <a:lstStyle/>
           <a:p>
             <a:r>
-              <a:rPr sz="1500" b="1">
+              <a:rPr sz="1500" b="1" dirty="0">
                 <a:solidFill>
                   <a:srgbClr val="D47A21"/>
                 </a:solidFill>
@@ -8831,6 +8868,166 @@
               </a:rPr>
               <a:t>Skills are reusable, shareable, and consistent. Write once, use every time.</a:t>
             </a:r>
+          </a:p>
+        </p:txBody>
+      </p:sp>
+      <p:sp>
+        <p:nvSpPr>
+          <p:cNvPr id="25" name="TextBox 24">
+            <a:extLst>
+              <a:ext uri="{FF2B5EF4-FFF2-40B4-BE49-F238E27FC236}">
+                <a16:creationId xmlns:a16="http://schemas.microsoft.com/office/drawing/2014/main" id="{811E2A0E-B402-90F6-861A-A42C753F5447}"/>
+              </a:ext>
+            </a:extLst>
+          </p:cNvPr>
+          <p:cNvSpPr txBox="1"/>
+          <p:nvPr/>
+        </p:nvSpPr>
+        <p:spPr>
+          <a:xfrm>
+            <a:off x="457200" y="6031468"/>
+            <a:ext cx="4217629" cy="369332"/>
+          </a:xfrm>
+          <a:prstGeom prst="rect">
+            <a:avLst/>
+          </a:prstGeom>
+          <a:noFill/>
+        </p:spPr>
+        <p:txBody>
+          <a:bodyPr wrap="none" rtlCol="0">
+            <a:spAutoFit/>
+          </a:bodyPr>
+          <a:lstStyle/>
+          <a:p>
+            <a:r>
+              <a:rPr lang="en-IN" b="1" dirty="0">
+                <a:solidFill>
+                  <a:srgbClr val="D47A21"/>
+                </a:solidFill>
+              </a:rPr>
+              <a:t>https://</a:t>
+            </a:r>
+            <a:r>
+              <a:rPr lang="en-IN" b="1" dirty="0" err="1">
+                <a:solidFill>
+                  <a:srgbClr val="D47A21"/>
+                </a:solidFill>
+              </a:rPr>
+              <a:t>github.com</a:t>
+            </a:r>
+            <a:r>
+              <a:rPr lang="en-IN" b="1" dirty="0">
+                <a:solidFill>
+                  <a:srgbClr val="D47A21"/>
+                </a:solidFill>
+              </a:rPr>
+              <a:t>/</a:t>
+            </a:r>
+            <a:r>
+              <a:rPr lang="en-IN" b="1" dirty="0" err="1">
+                <a:solidFill>
+                  <a:srgbClr val="D47A21"/>
+                </a:solidFill>
+              </a:rPr>
+              <a:t>qa-aman</a:t>
+            </a:r>
+            <a:r>
+              <a:rPr lang="en-IN" b="1" dirty="0">
+                <a:solidFill>
+                  <a:srgbClr val="D47A21"/>
+                </a:solidFill>
+              </a:rPr>
+              <a:t>/</a:t>
+            </a:r>
+            <a:r>
+              <a:rPr lang="en-IN" b="1" dirty="0" err="1">
+                <a:solidFill>
+                  <a:srgbClr val="D47A21"/>
+                </a:solidFill>
+              </a:rPr>
+              <a:t>claude</a:t>
+            </a:r>
+            <a:r>
+              <a:rPr lang="en-IN" b="1" dirty="0">
+                <a:solidFill>
+                  <a:srgbClr val="D47A21"/>
+                </a:solidFill>
+              </a:rPr>
+              <a:t>-skills</a:t>
+            </a:r>
+            <a:endParaRPr lang="en-US" dirty="0"/>
+          </a:p>
+        </p:txBody>
+      </p:sp>
+      <p:sp>
+        <p:nvSpPr>
+          <p:cNvPr id="31" name="TextBox 30">
+            <a:extLst>
+              <a:ext uri="{FF2B5EF4-FFF2-40B4-BE49-F238E27FC236}">
+                <a16:creationId xmlns:a16="http://schemas.microsoft.com/office/drawing/2014/main" id="{E881E02C-9C3C-029F-7783-64BAAD51D606}"/>
+              </a:ext>
+            </a:extLst>
+          </p:cNvPr>
+          <p:cNvSpPr txBox="1"/>
+          <p:nvPr/>
+        </p:nvSpPr>
+        <p:spPr>
+          <a:xfrm>
+            <a:off x="457200" y="5623334"/>
+            <a:ext cx="3969228" cy="369332"/>
+          </a:xfrm>
+          <a:prstGeom prst="rect">
+            <a:avLst/>
+          </a:prstGeom>
+          <a:noFill/>
+        </p:spPr>
+        <p:txBody>
+          <a:bodyPr wrap="none" rtlCol="0">
+            <a:spAutoFit/>
+          </a:bodyPr>
+          <a:lstStyle/>
+          <a:p>
+            <a:r>
+              <a:rPr lang="en-IN" b="1" dirty="0">
+                <a:solidFill>
+                  <a:srgbClr val="D47A21"/>
+                </a:solidFill>
+              </a:rPr>
+              <a:t>https://</a:t>
+            </a:r>
+            <a:r>
+              <a:rPr lang="en-IN" b="1" dirty="0" err="1">
+                <a:solidFill>
+                  <a:srgbClr val="D47A21"/>
+                </a:solidFill>
+              </a:rPr>
+              <a:t>code.claude.com</a:t>
+            </a:r>
+            <a:r>
+              <a:rPr lang="en-IN" b="1" dirty="0">
+                <a:solidFill>
+                  <a:srgbClr val="D47A21"/>
+                </a:solidFill>
+              </a:rPr>
+              <a:t>/docs/</a:t>
+            </a:r>
+            <a:r>
+              <a:rPr lang="en-IN" b="1" dirty="0" err="1">
+                <a:solidFill>
+                  <a:srgbClr val="D47A21"/>
+                </a:solidFill>
+              </a:rPr>
+              <a:t>en</a:t>
+            </a:r>
+            <a:r>
+              <a:rPr lang="en-IN" b="1" dirty="0">
+                <a:solidFill>
+                  <a:srgbClr val="D47A21"/>
+                </a:solidFill>
+              </a:rPr>
+              <a:t>/skills</a:t>
+            </a:r>
+            <a:endParaRPr lang="en-US" dirty="0"/>
           </a:p>
         </p:txBody>
       </p:sp>
@@ -10349,28 +10546,28 @@
         </p:nvSpPr>
         <p:spPr>
           <a:xfrm>
-            <a:off x="548640" y="548640"/>
-            <a:ext cx="10058400" cy="914400"/>
-          </a:xfrm>
-          <a:prstGeom prst="rect">
-            <a:avLst/>
-          </a:prstGeom>
-          <a:noFill/>
-        </p:spPr>
-        <p:txBody>
-          <a:bodyPr wrap="square">
-            <a:spAutoFit/>
-          </a:bodyPr>
-          <a:lstStyle/>
-          <a:p>
-            <a:pPr algn="l"/>
-            <a:r>
-              <a:rPr sz="3600" b="1">
+            <a:off x="422160" y="582094"/>
+            <a:ext cx="11064240" cy="1371600"/>
+          </a:xfrm>
+          <a:prstGeom prst="rect">
+            <a:avLst/>
+          </a:prstGeom>
+          <a:noFill/>
+        </p:spPr>
+        <p:txBody>
+          <a:bodyPr wrap="square">
+            <a:spAutoFit/>
+          </a:bodyPr>
+          <a:lstStyle/>
+          <a:p>
+            <a:pPr algn="ctr"/>
+            <a:r>
+              <a:rPr sz="7200" b="1" dirty="0">
                 <a:solidFill>
                   <a:srgbClr val="FFFFFF"/>
                 </a:solidFill>
               </a:rPr>
-              <a:t>Let's Stay Connected</a:t>
+              <a:t>Thank You</a:t>
             </a:r>
           </a:p>
         </p:txBody>
@@ -10383,8 +10580,8 @@
         </p:nvSpPr>
         <p:spPr>
           <a:xfrm>
-            <a:off x="548640" y="1508760"/>
-            <a:ext cx="11064240" cy="19050"/>
+            <a:off x="3501483" y="1862161"/>
+            <a:ext cx="4937760" cy="19050"/>
           </a:xfrm>
           <a:prstGeom prst="rect">
             <a:avLst/>
@@ -10427,28 +10624,28 @@
         </p:nvSpPr>
         <p:spPr>
           <a:xfrm>
-            <a:off x="548640" y="1737360"/>
-            <a:ext cx="10058400" cy="457200"/>
-          </a:xfrm>
-          <a:prstGeom prst="rect">
-            <a:avLst/>
-          </a:prstGeom>
-          <a:noFill/>
-        </p:spPr>
-        <p:txBody>
-          <a:bodyPr wrap="square">
-            <a:spAutoFit/>
-          </a:bodyPr>
-          <a:lstStyle/>
-          <a:p>
-            <a:pPr algn="l"/>
-            <a:r>
-              <a:rPr sz="1800">
+            <a:off x="422160" y="2057960"/>
+            <a:ext cx="11064240" cy="640080"/>
+          </a:xfrm>
+          <a:prstGeom prst="rect">
+            <a:avLst/>
+          </a:prstGeom>
+          <a:noFill/>
+        </p:spPr>
+        <p:txBody>
+          <a:bodyPr wrap="square">
+            <a:spAutoFit/>
+          </a:bodyPr>
+          <a:lstStyle/>
+          <a:p>
+            <a:pPr algn="ctr"/>
+            <a:r>
+              <a:rPr sz="2400" dirty="0">
                 <a:solidFill>
                   <a:srgbClr val="888888"/>
                 </a:solidFill>
               </a:rPr>
-              <a:t>Reach out anytime. Happy to help.</a:t>
+              <a:t>Now go build something.</a:t>
             </a:r>
           </a:p>
         </p:txBody>
@@ -10461,23 +10658,57 @@
         </p:nvSpPr>
         <p:spPr>
           <a:xfrm>
-            <a:off x="548640" y="2468880"/>
-            <a:ext cx="2743200" cy="457200"/>
-          </a:xfrm>
-          <a:prstGeom prst="rect">
-            <a:avLst/>
-          </a:prstGeom>
-          <a:noFill/>
-        </p:spPr>
-        <p:txBody>
-          <a:bodyPr wrap="square">
-            <a:spAutoFit/>
-          </a:bodyPr>
-          <a:lstStyle/>
-          <a:p>
-            <a:pPr algn="l"/>
-            <a:r>
-              <a:rPr sz="1800" b="1">
+            <a:off x="548640" y="5852160"/>
+            <a:ext cx="11064240" cy="292388"/>
+          </a:xfrm>
+          <a:prstGeom prst="rect">
+            <a:avLst/>
+          </a:prstGeom>
+          <a:noFill/>
+        </p:spPr>
+        <p:txBody>
+          <a:bodyPr wrap="square">
+            <a:spAutoFit/>
+          </a:bodyPr>
+          <a:lstStyle/>
+          <a:p>
+            <a:pPr algn="ctr"/>
+            <a:r>
+              <a:rPr sz="1300" dirty="0">
+                <a:solidFill>
+                  <a:srgbClr val="888888"/>
+                </a:solidFill>
+              </a:rPr>
+              <a:t>NEXTLEAP  ·  APPLIED GENAI BOOTCAMP </a:t>
+            </a:r>
+          </a:p>
+        </p:txBody>
+      </p:sp>
+      <p:sp>
+        <p:nvSpPr>
+          <p:cNvPr id="7" name="TextBox 6"/>
+          <p:cNvSpPr txBox="1"/>
+          <p:nvPr/>
+        </p:nvSpPr>
+        <p:spPr>
+          <a:xfrm>
+            <a:off x="3055434" y="3117922"/>
+            <a:ext cx="2000000" cy="369332"/>
+          </a:xfrm>
+          <a:prstGeom prst="rect">
+            <a:avLst/>
+          </a:prstGeom>
+          <a:noFill/>
+        </p:spPr>
+        <p:txBody>
+          <a:bodyPr wrap="none">
+            <a:spAutoFit/>
+          </a:bodyPr>
+          <a:lstStyle/>
+          <a:p>
+            <a:pPr algn="r"/>
+            <a:r>
+              <a:rPr sz="1600" b="1">
                 <a:solidFill>
                   <a:srgbClr val="D47A21"/>
                 </a:solidFill>
@@ -10489,29 +10720,28 @@
       </p:sp>
       <p:sp>
         <p:nvSpPr>
-          <p:cNvPr id="7" name="TextBox 6"/>
-          <p:cNvSpPr txBox="1"/>
-          <p:nvPr/>
-        </p:nvSpPr>
-        <p:spPr>
-          <a:xfrm>
-            <a:off x="3474720" y="2468880"/>
-            <a:ext cx="7772400" cy="457200"/>
-          </a:xfrm>
-          <a:prstGeom prst="rect">
-            <a:avLst/>
-          </a:prstGeom>
-          <a:noFill/>
-        </p:spPr>
-        <p:txBody>
-          <a:bodyPr wrap="square">
-            <a:spAutoFit/>
-          </a:bodyPr>
-          <a:lstStyle/>
-          <a:p>
-            <a:pPr algn="l"/>
-            <a:r>
-              <a:rPr sz="1800" dirty="0">
+          <p:cNvPr id="8" name="TextBox 7"/>
+          <p:cNvSpPr txBox="1"/>
+          <p:nvPr/>
+        </p:nvSpPr>
+        <p:spPr>
+          <a:xfrm>
+            <a:off x="5341434" y="3117922"/>
+            <a:ext cx="6000000" cy="369332"/>
+          </a:xfrm>
+          <a:prstGeom prst="rect">
+            <a:avLst/>
+          </a:prstGeom>
+          <a:noFill/>
+        </p:spPr>
+        <p:txBody>
+          <a:bodyPr wrap="none">
+            <a:spAutoFit/>
+          </a:bodyPr>
+          <a:lstStyle/>
+          <a:p>
+            <a:r>
+              <a:rPr sz="1600">
                 <a:solidFill>
                   <a:srgbClr val="FFFFFF"/>
                 </a:solidFill>
@@ -10524,29 +10754,29 @@
       </p:sp>
       <p:sp>
         <p:nvSpPr>
-          <p:cNvPr id="8" name="TextBox 7"/>
-          <p:cNvSpPr txBox="1"/>
-          <p:nvPr/>
-        </p:nvSpPr>
-        <p:spPr>
-          <a:xfrm>
-            <a:off x="548640" y="3200400"/>
-            <a:ext cx="2743200" cy="457200"/>
-          </a:xfrm>
-          <a:prstGeom prst="rect">
-            <a:avLst/>
-          </a:prstGeom>
-          <a:noFill/>
-        </p:spPr>
-        <p:txBody>
-          <a:bodyPr wrap="square">
-            <a:spAutoFit/>
-          </a:bodyPr>
-          <a:lstStyle/>
-          <a:p>
-            <a:pPr algn="l"/>
-            <a:r>
-              <a:rPr sz="1800" b="1">
+          <p:cNvPr id="9" name="TextBox 8"/>
+          <p:cNvSpPr txBox="1"/>
+          <p:nvPr/>
+        </p:nvSpPr>
+        <p:spPr>
+          <a:xfrm>
+            <a:off x="3055434" y="3617922"/>
+            <a:ext cx="2000000" cy="369332"/>
+          </a:xfrm>
+          <a:prstGeom prst="rect">
+            <a:avLst/>
+          </a:prstGeom>
+          <a:noFill/>
+        </p:spPr>
+        <p:txBody>
+          <a:bodyPr wrap="none">
+            <a:spAutoFit/>
+          </a:bodyPr>
+          <a:lstStyle/>
+          <a:p>
+            <a:pPr algn="r"/>
+            <a:r>
+              <a:rPr sz="1600" b="1">
                 <a:solidFill>
                   <a:srgbClr val="D47A21"/>
                 </a:solidFill>
@@ -10558,29 +10788,28 @@
       </p:sp>
       <p:sp>
         <p:nvSpPr>
-          <p:cNvPr id="9" name="TextBox 8"/>
-          <p:cNvSpPr txBox="1"/>
-          <p:nvPr/>
-        </p:nvSpPr>
-        <p:spPr>
-          <a:xfrm>
-            <a:off x="3474720" y="3200400"/>
-            <a:ext cx="7772400" cy="457200"/>
-          </a:xfrm>
-          <a:prstGeom prst="rect">
-            <a:avLst/>
-          </a:prstGeom>
-          <a:noFill/>
-        </p:spPr>
-        <p:txBody>
-          <a:bodyPr wrap="square">
-            <a:spAutoFit/>
-          </a:bodyPr>
-          <a:lstStyle/>
-          <a:p>
-            <a:pPr algn="l"/>
-            <a:r>
-              <a:rPr sz="1800">
+          <p:cNvPr id="10" name="TextBox 9"/>
+          <p:cNvSpPr txBox="1"/>
+          <p:nvPr/>
+        </p:nvSpPr>
+        <p:spPr>
+          <a:xfrm>
+            <a:off x="5341434" y="3617922"/>
+            <a:ext cx="6000000" cy="369332"/>
+          </a:xfrm>
+          <a:prstGeom prst="rect">
+            <a:avLst/>
+          </a:prstGeom>
+          <a:noFill/>
+        </p:spPr>
+        <p:txBody>
+          <a:bodyPr wrap="none">
+            <a:spAutoFit/>
+          </a:bodyPr>
+          <a:lstStyle/>
+          <a:p>
+            <a:r>
+              <a:rPr sz="1600">
                 <a:solidFill>
                   <a:srgbClr val="FFFFFF"/>
                 </a:solidFill>
@@ -10593,29 +10822,29 @@
       </p:sp>
       <p:sp>
         <p:nvSpPr>
-          <p:cNvPr id="10" name="TextBox 9"/>
-          <p:cNvSpPr txBox="1"/>
-          <p:nvPr/>
-        </p:nvSpPr>
-        <p:spPr>
-          <a:xfrm>
-            <a:off x="548640" y="3931920"/>
-            <a:ext cx="2743200" cy="457200"/>
-          </a:xfrm>
-          <a:prstGeom prst="rect">
-            <a:avLst/>
-          </a:prstGeom>
-          <a:noFill/>
-        </p:spPr>
-        <p:txBody>
-          <a:bodyPr wrap="square">
-            <a:spAutoFit/>
-          </a:bodyPr>
-          <a:lstStyle/>
-          <a:p>
-            <a:pPr algn="l"/>
-            <a:r>
-              <a:rPr sz="1800" b="1">
+          <p:cNvPr id="11" name="TextBox 10"/>
+          <p:cNvSpPr txBox="1"/>
+          <p:nvPr/>
+        </p:nvSpPr>
+        <p:spPr>
+          <a:xfrm>
+            <a:off x="3055434" y="4117922"/>
+            <a:ext cx="2000000" cy="369332"/>
+          </a:xfrm>
+          <a:prstGeom prst="rect">
+            <a:avLst/>
+          </a:prstGeom>
+          <a:noFill/>
+        </p:spPr>
+        <p:txBody>
+          <a:bodyPr wrap="none">
+            <a:spAutoFit/>
+          </a:bodyPr>
+          <a:lstStyle/>
+          <a:p>
+            <a:pPr algn="r"/>
+            <a:r>
+              <a:rPr sz="1600" b="1">
                 <a:solidFill>
                   <a:srgbClr val="D47A21"/>
                 </a:solidFill>
@@ -10627,69 +10856,34 @@
       </p:sp>
       <p:sp>
         <p:nvSpPr>
-          <p:cNvPr id="11" name="TextBox 10"/>
-          <p:cNvSpPr txBox="1"/>
-          <p:nvPr/>
-        </p:nvSpPr>
-        <p:spPr>
-          <a:xfrm>
-            <a:off x="3474720" y="3931920"/>
-            <a:ext cx="7772400" cy="457200"/>
-          </a:xfrm>
-          <a:prstGeom prst="rect">
-            <a:avLst/>
-          </a:prstGeom>
-          <a:noFill/>
-        </p:spPr>
-        <p:txBody>
-          <a:bodyPr wrap="square">
-            <a:spAutoFit/>
-          </a:bodyPr>
-          <a:lstStyle/>
-          <a:p>
-            <a:pPr algn="l"/>
-            <a:r>
-              <a:rPr sz="1800">
+          <p:cNvPr id="12" name="TextBox 11"/>
+          <p:cNvSpPr txBox="1"/>
+          <p:nvPr/>
+        </p:nvSpPr>
+        <p:spPr>
+          <a:xfrm>
+            <a:off x="5341434" y="4117922"/>
+            <a:ext cx="6000000" cy="369332"/>
+          </a:xfrm>
+          <a:prstGeom prst="rect">
+            <a:avLst/>
+          </a:prstGeom>
+          <a:noFill/>
+        </p:spPr>
+        <p:txBody>
+          <a:bodyPr wrap="none">
+            <a:spAutoFit/>
+          </a:bodyPr>
+          <a:lstStyle/>
+          <a:p>
+            <a:r>
+              <a:rPr sz="1600">
                 <a:solidFill>
                   <a:srgbClr val="FFFFFF"/>
                 </a:solidFill>
                 <a:hlinkClick r:id="rId4"/>
               </a:rPr>
               <a:t>github.com/qa-aman</a:t>
-            </a:r>
-          </a:p>
-        </p:txBody>
-      </p:sp>
-      <p:sp>
-        <p:nvSpPr>
-          <p:cNvPr id="12" name="TextBox 11"/>
-          <p:cNvSpPr txBox="1"/>
-          <p:nvPr/>
-        </p:nvSpPr>
-        <p:spPr>
-          <a:xfrm>
-            <a:off x="548640" y="5852160"/>
-            <a:ext cx="10058400" cy="457200"/>
-          </a:xfrm>
-          <a:prstGeom prst="rect">
-            <a:avLst/>
-          </a:prstGeom>
-          <a:noFill/>
-        </p:spPr>
-        <p:txBody>
-          <a:bodyPr wrap="square">
-            <a:spAutoFit/>
-          </a:bodyPr>
-          <a:lstStyle/>
-          <a:p>
-            <a:pPr algn="l"/>
-            <a:r>
-              <a:rPr sz="1600" b="1">
-                <a:solidFill>
-                  <a:srgbClr val="D47A21"/>
-                </a:solidFill>
-              </a:rPr>
-              <a:t>DMs are open. Questions welcome anytime.</a:t>
             </a:r>
           </a:p>
         </p:txBody>
@@ -11235,229 +11429,6 @@
 </p:sld>
 </file>
 
-<file path=ppt/slides/slide20.xml><?xml version="1.0" encoding="utf-8"?>
-<p:sld xmlns:a="http://schemas.openxmlformats.org/drawingml/2006/main" xmlns:r="http://schemas.openxmlformats.org/officeDocument/2006/relationships" xmlns:p="http://schemas.openxmlformats.org/presentationml/2006/main">
-  <p:cSld>
-    <p:bg>
-      <p:bgPr>
-        <a:solidFill>
-          <a:srgbClr val="0D0D0D"/>
-        </a:solidFill>
-        <a:effectLst/>
-      </p:bgPr>
-    </p:bg>
-    <p:spTree>
-      <p:nvGrpSpPr>
-        <p:cNvPr id="1" name=""/>
-        <p:cNvGrpSpPr/>
-        <p:nvPr/>
-      </p:nvGrpSpPr>
-      <p:grpSpPr>
-        <a:xfrm>
-          <a:off x="0" y="0"/>
-          <a:ext cx="0" cy="0"/>
-          <a:chOff x="0" y="0"/>
-          <a:chExt cx="0" cy="0"/>
-        </a:xfrm>
-      </p:grpSpPr>
-      <p:sp>
-        <p:nvSpPr>
-          <p:cNvPr id="2" name="Rectangle 1"/>
-          <p:cNvSpPr/>
-          <p:nvPr/>
-        </p:nvSpPr>
-        <p:spPr>
-          <a:xfrm>
-            <a:off x="0" y="164592"/>
-            <a:ext cx="12188952" cy="54864"/>
-          </a:xfrm>
-          <a:prstGeom prst="rect">
-            <a:avLst/>
-          </a:prstGeom>
-          <a:solidFill>
-            <a:srgbClr val="D47A21"/>
-          </a:solidFill>
-          <a:ln>
-            <a:noFill/>
-          </a:ln>
-        </p:spPr>
-        <p:style>
-          <a:lnRef idx="1">
-            <a:schemeClr val="accent1"/>
-          </a:lnRef>
-          <a:fillRef idx="3">
-            <a:schemeClr val="accent1"/>
-          </a:fillRef>
-          <a:effectRef idx="2">
-            <a:schemeClr val="accent1"/>
-          </a:effectRef>
-          <a:fontRef idx="minor">
-            <a:schemeClr val="lt1"/>
-          </a:fontRef>
-        </p:style>
-        <p:txBody>
-          <a:bodyPr rtlCol="0" anchor="ctr"/>
-          <a:lstStyle/>
-          <a:p>
-            <a:pPr algn="ctr"/>
-            <a:endParaRPr/>
-          </a:p>
-        </p:txBody>
-      </p:sp>
-      <p:sp>
-        <p:nvSpPr>
-          <p:cNvPr id="3" name="TextBox 2"/>
-          <p:cNvSpPr txBox="1"/>
-          <p:nvPr/>
-        </p:nvSpPr>
-        <p:spPr>
-          <a:xfrm>
-            <a:off x="548640" y="1920240"/>
-            <a:ext cx="11064240" cy="1371600"/>
-          </a:xfrm>
-          <a:prstGeom prst="rect">
-            <a:avLst/>
-          </a:prstGeom>
-          <a:noFill/>
-        </p:spPr>
-        <p:txBody>
-          <a:bodyPr wrap="square">
-            <a:spAutoFit/>
-          </a:bodyPr>
-          <a:lstStyle/>
-          <a:p>
-            <a:pPr algn="ctr"/>
-            <a:r>
-              <a:rPr sz="7200" b="1">
-                <a:solidFill>
-                  <a:srgbClr val="FFFFFF"/>
-                </a:solidFill>
-              </a:rPr>
-              <a:t>Thank You</a:t>
-            </a:r>
-          </a:p>
-        </p:txBody>
-      </p:sp>
-      <p:sp>
-        <p:nvSpPr>
-          <p:cNvPr id="4" name="Rectangle 3"/>
-          <p:cNvSpPr/>
-          <p:nvPr/>
-        </p:nvSpPr>
-        <p:spPr>
-          <a:xfrm>
-            <a:off x="3657600" y="3474720"/>
-            <a:ext cx="4937760" cy="19050"/>
-          </a:xfrm>
-          <a:prstGeom prst="rect">
-            <a:avLst/>
-          </a:prstGeom>
-          <a:solidFill>
-            <a:srgbClr val="D47A21"/>
-          </a:solidFill>
-          <a:ln>
-            <a:noFill/>
-          </a:ln>
-        </p:spPr>
-        <p:style>
-          <a:lnRef idx="1">
-            <a:schemeClr val="accent1"/>
-          </a:lnRef>
-          <a:fillRef idx="3">
-            <a:schemeClr val="accent1"/>
-          </a:fillRef>
-          <a:effectRef idx="2">
-            <a:schemeClr val="accent1"/>
-          </a:effectRef>
-          <a:fontRef idx="minor">
-            <a:schemeClr val="lt1"/>
-          </a:fontRef>
-        </p:style>
-        <p:txBody>
-          <a:bodyPr rtlCol="0" anchor="ctr"/>
-          <a:lstStyle/>
-          <a:p>
-            <a:pPr algn="ctr"/>
-            <a:endParaRPr/>
-          </a:p>
-        </p:txBody>
-      </p:sp>
-      <p:sp>
-        <p:nvSpPr>
-          <p:cNvPr id="5" name="TextBox 4"/>
-          <p:cNvSpPr txBox="1"/>
-          <p:nvPr/>
-        </p:nvSpPr>
-        <p:spPr>
-          <a:xfrm>
-            <a:off x="548640" y="3749040"/>
-            <a:ext cx="11064240" cy="640080"/>
-          </a:xfrm>
-          <a:prstGeom prst="rect">
-            <a:avLst/>
-          </a:prstGeom>
-          <a:noFill/>
-        </p:spPr>
-        <p:txBody>
-          <a:bodyPr wrap="square">
-            <a:spAutoFit/>
-          </a:bodyPr>
-          <a:lstStyle/>
-          <a:p>
-            <a:pPr algn="ctr"/>
-            <a:r>
-              <a:rPr sz="2400">
-                <a:solidFill>
-                  <a:srgbClr val="888888"/>
-                </a:solidFill>
-              </a:rPr>
-              <a:t>Now go build something.</a:t>
-            </a:r>
-          </a:p>
-        </p:txBody>
-      </p:sp>
-      <p:sp>
-        <p:nvSpPr>
-          <p:cNvPr id="6" name="TextBox 5"/>
-          <p:cNvSpPr txBox="1"/>
-          <p:nvPr/>
-        </p:nvSpPr>
-        <p:spPr>
-          <a:xfrm>
-            <a:off x="548640" y="5852160"/>
-            <a:ext cx="11064240" cy="292388"/>
-          </a:xfrm>
-          <a:prstGeom prst="rect">
-            <a:avLst/>
-          </a:prstGeom>
-          <a:noFill/>
-        </p:spPr>
-        <p:txBody>
-          <a:bodyPr wrap="square">
-            <a:spAutoFit/>
-          </a:bodyPr>
-          <a:lstStyle/>
-          <a:p>
-            <a:pPr algn="ctr"/>
-            <a:r>
-              <a:rPr sz="1300" dirty="0">
-                <a:solidFill>
-                  <a:srgbClr val="888888"/>
-                </a:solidFill>
-              </a:rPr>
-              <a:t>NEXTLEAP  ·  APPLIED GENAI BOOTCAMP </a:t>
-            </a:r>
-          </a:p>
-        </p:txBody>
-      </p:sp>
-    </p:spTree>
-  </p:cSld>
-  <p:clrMapOvr>
-    <a:masterClrMapping/>
-  </p:clrMapOvr>
-</p:sld>
-</file>
-
 <file path=ppt/slides/slide3.xml><?xml version="1.0" encoding="utf-8"?>
 <p:sld xmlns:a="http://schemas.openxmlformats.org/drawingml/2006/main" xmlns:r="http://schemas.openxmlformats.org/officeDocument/2006/relationships" xmlns:p="http://schemas.openxmlformats.org/presentationml/2006/main">
   <p:cSld>
@@ -11670,7 +11641,7 @@
                   <a:srgbClr val="CCCCCC"/>
                 </a:solidFill>
               </a:rPr>
-              <a:t>  Claude Code is the step between 'user' and 'builder'.</a:t>
+              <a:t>Claude Code is the step between 'user' and 'builder'.</a:t>
             </a:r>
           </a:p>
           <a:p>
@@ -11685,7 +11656,7 @@
                   <a:srgbClr val="CCCCCC"/>
                 </a:solidFill>
               </a:rPr>
-              <a:t>  The terminal is not scary — it's just a faster keyboard.</a:t>
+              <a:t>The terminal is not scary — it's just a faster keyboard.</a:t>
             </a:r>
           </a:p>
         </p:txBody>

</xml_diff>